<commit_message>
Use official Dawodia Holding logo and brand colours in values deck
Replace the placeholder wordmark with the round logo badge in the
corner of every slide, and move the palette from navy/gold to the
logo's burgundy, crimson and silver.

Co-Authored-By: Claude Opus 5.5 <noreply@anthropic.com>
Claude-Session: https://claude.ai/code/session_01MNuDATT8ydr54HKqok1xEZ
</commit_message>
<xml_diff>
--- a/presentation/Dawodia_Holding_Our_Values.pptx
+++ b/presentation/Dawodia_Holding_Our_Values.pptx
@@ -1610,8 +1610,8 @@
         </p:blipFill>
         <p:spPr>
           <a:xfrm>
-            <a:off x="548640" y="502920"/>
-            <a:ext cx="2377440" cy="742950"/>
+            <a:off x="548640" y="457200"/>
+            <a:ext cx="914400" cy="914400"/>
           </a:xfrm>
           <a:prstGeom prst="rect">
             <a:avLst/>
@@ -1626,8 +1626,8 @@
         </p:nvSpPr>
         <p:spPr>
           <a:xfrm>
-            <a:off x="548640" y="1737360"/>
-            <a:ext cx="5486400" cy="274320"/>
+            <a:off x="1645920" y="566928"/>
+            <a:ext cx="3657600" cy="694944"/>
           </a:xfrm>
           <a:prstGeom prst="rect">
             <a:avLst/>
@@ -1643,70 +1643,126 @@
               <a:buNone/>
             </a:pPr>
             <a:r>
-              <a:rPr lang="en-US" sz="1100" b="1" spc="500" kern="0" dirty="0">
-                <a:solidFill>
-                  <a:srgbClr val="C8A04A"/>
+              <a:rPr lang="en-US" sz="2000" b="1" spc="600" kern="0" dirty="0">
+                <a:solidFill>
+                  <a:srgbClr val="FFFFFF"/>
                 </a:solidFill>
                 <a:latin typeface="Arial" pitchFamily="34" charset="0"/>
                 <a:ea typeface="Arial" pitchFamily="34" charset="-122"/>
                 <a:cs typeface="Arial" pitchFamily="34" charset="-120"/>
               </a:rPr>
-              <a:t>COMPANY VALUES  ·  2026</a:t>
-            </a:r>
-            <a:endParaRPr lang="en-US" sz="1100" dirty="0"/>
-          </a:p>
-        </p:txBody>
-      </p:sp>
-      <p:sp>
-        <p:nvSpPr>
-          <p:cNvPr id="4" name="Text 1"/>
-          <p:cNvSpPr txBox="1"/>
-          <p:nvPr/>
-        </p:nvSpPr>
-        <p:spPr>
-          <a:xfrm>
-            <a:off x="548640" y="2057400"/>
-            <a:ext cx="6400800" cy="1463040"/>
-          </a:xfrm>
-          <a:prstGeom prst="rect">
-            <a:avLst/>
-          </a:prstGeom>
-          <a:noFill/>
-          <a:ln/>
-        </p:spPr>
-        <p:txBody>
-          <a:bodyPr wrap="square" lIns="0" tIns="0" rIns="0" bIns="0" rtlCol="0" anchor="t"/>
-          <a:lstStyle/>
+              <a:t>DAWODIA</a:t>
+            </a:r>
+            <a:endParaRPr lang="en-US" sz="2000" dirty="0"/>
+          </a:p>
           <a:p>
             <a:pPr indent="0" marL="0">
               <a:buNone/>
             </a:pPr>
             <a:r>
-              <a:rPr lang="en-US" sz="4400" b="1" dirty="0">
-                <a:solidFill>
-                  <a:srgbClr val="FFFFFF"/>
+              <a:rPr lang="en-US" sz="1100" spc="1000" kern="0" dirty="0">
+                <a:solidFill>
+                  <a:srgbClr val="D6D9DE"/>
                 </a:solidFill>
                 <a:latin typeface="Arial" pitchFamily="34" charset="0"/>
                 <a:ea typeface="Arial" pitchFamily="34" charset="-122"/>
                 <a:cs typeface="Arial" pitchFamily="34" charset="-120"/>
               </a:rPr>
-              <a:t>Our Values,</a:t>
-            </a:r>
-            <a:endParaRPr lang="en-US" sz="4400" dirty="0"/>
-          </a:p>
+              <a:t>HOLDING</a:t>
+            </a:r>
+            <a:endParaRPr lang="en-US" sz="2000" dirty="0"/>
+          </a:p>
+        </p:txBody>
+      </p:sp>
+      <p:sp>
+        <p:nvSpPr>
+          <p:cNvPr id="4" name="Text 1"/>
+          <p:cNvSpPr txBox="1"/>
+          <p:nvPr/>
+        </p:nvSpPr>
+        <p:spPr>
+          <a:xfrm>
+            <a:off x="548640" y="1737360"/>
+            <a:ext cx="5486400" cy="274320"/>
+          </a:xfrm>
+          <a:prstGeom prst="rect">
+            <a:avLst/>
+          </a:prstGeom>
+          <a:noFill/>
+          <a:ln/>
+        </p:spPr>
+        <p:txBody>
+          <a:bodyPr wrap="square" lIns="0" tIns="0" rIns="0" bIns="0" rtlCol="0" anchor="ctr"/>
+          <a:lstStyle/>
           <a:p>
             <a:pPr indent="0" marL="0">
               <a:buNone/>
             </a:pPr>
             <a:r>
-              <a:rPr lang="en-US" sz="4400" b="1" dirty="0">
-                <a:solidFill>
-                  <a:srgbClr val="FFFFFF"/>
+              <a:rPr lang="en-US" sz="1100" b="1" spc="500" kern="0" dirty="0">
+                <a:solidFill>
+                  <a:srgbClr val="D6D9DE"/>
                 </a:solidFill>
                 <a:latin typeface="Arial" pitchFamily="34" charset="0"/>
                 <a:ea typeface="Arial" pitchFamily="34" charset="-122"/>
                 <a:cs typeface="Arial" pitchFamily="34" charset="-120"/>
               </a:rPr>
+              <a:t>COMPANY VALUES  ·  2026</a:t>
+            </a:r>
+            <a:endParaRPr lang="en-US" sz="1100" dirty="0"/>
+          </a:p>
+        </p:txBody>
+      </p:sp>
+      <p:sp>
+        <p:nvSpPr>
+          <p:cNvPr id="5" name="Text 2"/>
+          <p:cNvSpPr txBox="1"/>
+          <p:nvPr/>
+        </p:nvSpPr>
+        <p:spPr>
+          <a:xfrm>
+            <a:off x="548640" y="2057400"/>
+            <a:ext cx="6400800" cy="1463040"/>
+          </a:xfrm>
+          <a:prstGeom prst="rect">
+            <a:avLst/>
+          </a:prstGeom>
+          <a:noFill/>
+          <a:ln/>
+        </p:spPr>
+        <p:txBody>
+          <a:bodyPr wrap="square" lIns="0" tIns="0" rIns="0" bIns="0" rtlCol="0" anchor="t"/>
+          <a:lstStyle/>
+          <a:p>
+            <a:pPr indent="0" marL="0">
+              <a:buNone/>
+            </a:pPr>
+            <a:r>
+              <a:rPr lang="en-US" sz="4400" b="1" dirty="0">
+                <a:solidFill>
+                  <a:srgbClr val="FFFFFF"/>
+                </a:solidFill>
+                <a:latin typeface="Arial" pitchFamily="34" charset="0"/>
+                <a:ea typeface="Arial" pitchFamily="34" charset="-122"/>
+                <a:cs typeface="Arial" pitchFamily="34" charset="-120"/>
+              </a:rPr>
+              <a:t>Our Values,</a:t>
+            </a:r>
+            <a:endParaRPr lang="en-US" sz="4400" dirty="0"/>
+          </a:p>
+          <a:p>
+            <a:pPr indent="0" marL="0">
+              <a:buNone/>
+            </a:pPr>
+            <a:r>
+              <a:rPr lang="en-US" sz="4400" b="1" dirty="0">
+                <a:solidFill>
+                  <a:srgbClr val="FFFFFF"/>
+                </a:solidFill>
+                <a:latin typeface="Arial" pitchFamily="34" charset="0"/>
+                <a:ea typeface="Arial" pitchFamily="34" charset="-122"/>
+                <a:cs typeface="Arial" pitchFamily="34" charset="-120"/>
+              </a:rPr>
               <a:t>Our Direction</a:t>
             </a:r>
             <a:endParaRPr lang="en-US" sz="4400" dirty="0"/>
@@ -1715,7 +1771,7 @@
       </p:sp>
       <p:sp>
         <p:nvSpPr>
-          <p:cNvPr id="5" name="Text 2"/>
+          <p:cNvPr id="6" name="Text 3"/>
           <p:cNvSpPr txBox="1"/>
           <p:nvPr/>
         </p:nvSpPr>
@@ -1740,7 +1796,7 @@
             <a:r>
               <a:rPr lang="en-US" sz="1800" i="1" dirty="0">
                 <a:solidFill>
-                  <a:srgbClr val="D5DEE8"/>
+                  <a:srgbClr val="F1E1E7"/>
                 </a:solidFill>
                 <a:latin typeface="Cambria" pitchFamily="34" charset="0"/>
                 <a:ea typeface="Cambria" pitchFamily="34" charset="-122"/>
@@ -1754,7 +1810,7 @@
       </p:sp>
       <p:sp>
         <p:nvSpPr>
-          <p:cNvPr id="6" name="Text 3"/>
+          <p:cNvPr id="7" name="Text 4"/>
           <p:cNvSpPr txBox="1"/>
           <p:nvPr/>
         </p:nvSpPr>
@@ -1779,7 +1835,7 @@
             <a:r>
               <a:rPr lang="en-US" sz="1000" spc="100" kern="0" dirty="0">
                 <a:solidFill>
-                  <a:srgbClr val="8FA3B8"/>
+                  <a:srgbClr val="D2B3BF"/>
                 </a:solidFill>
                 <a:latin typeface="Arial" pitchFamily="34" charset="0"/>
                 <a:ea typeface="Arial" pitchFamily="34" charset="-122"/>
@@ -1873,7 +1929,7 @@
             <a:r>
               <a:rPr lang="en-US" sz="6000" b="1" dirty="0">
                 <a:solidFill>
-                  <a:srgbClr val="C8A04A"/>
+                  <a:srgbClr val="D6D9DE"/>
                 </a:solidFill>
                 <a:latin typeface="Arial" pitchFamily="34" charset="0"/>
                 <a:ea typeface="Arial" pitchFamily="34" charset="-122"/>
@@ -1912,7 +1968,7 @@
             <a:r>
               <a:rPr lang="en-US" sz="1100" b="1" spc="500" kern="0" dirty="0">
                 <a:solidFill>
-                  <a:srgbClr val="D5DEE8"/>
+                  <a:srgbClr val="F1E1E7"/>
                 </a:solidFill>
                 <a:latin typeface="Arial" pitchFamily="34" charset="0"/>
                 <a:ea typeface="Arial" pitchFamily="34" charset="-122"/>
@@ -2024,7 +2080,7 @@
             <a:r>
               <a:rPr lang="en-US" sz="800" spc="200" kern="0" dirty="0">
                 <a:solidFill>
-                  <a:srgbClr val="8FA3B8"/>
+                  <a:srgbClr val="D2B3BF"/>
                 </a:solidFill>
                 <a:latin typeface="Arial" pitchFamily="34" charset="0"/>
                 <a:ea typeface="Arial" pitchFamily="34" charset="-122"/>
@@ -2063,7 +2119,7 @@
             <a:r>
               <a:rPr lang="en-US" sz="800" dirty="0">
                 <a:solidFill>
-                  <a:srgbClr val="8A94A1"/>
+                  <a:srgbClr val="9A8C92"/>
                 </a:solidFill>
                 <a:latin typeface="Arial" pitchFamily="34" charset="0"/>
                 <a:ea typeface="Arial" pitchFamily="34" charset="-122"/>
@@ -2091,8 +2147,8 @@
         </p:blipFill>
         <p:spPr>
           <a:xfrm>
-            <a:off x="7452360" y="274320"/>
-            <a:ext cx="1325880" cy="414337"/>
+            <a:off x="8211312" y="182880"/>
+            <a:ext cx="566928" cy="566928"/>
           </a:xfrm>
           <a:prstGeom prst="rect">
             <a:avLst/>
@@ -2114,11 +2170,11 @@
             <a:avLst/>
           </a:prstGeom>
           <a:solidFill>
-            <a:srgbClr val="F4ECD8"/>
+            <a:srgbClr val="F9E8EE"/>
           </a:solidFill>
           <a:ln w="12700">
             <a:solidFill>
-              <a:srgbClr val="F4ECD8"/>
+              <a:srgbClr val="F9E8EE"/>
             </a:solidFill>
             <a:prstDash val="solid"/>
           </a:ln>
@@ -2175,7 +2231,7 @@
             <a:r>
               <a:rPr lang="en-US" sz="1500" dirty="0">
                 <a:solidFill>
-                  <a:srgbClr val="1B2733"/>
+                  <a:srgbClr val="221A1D"/>
                 </a:solidFill>
                 <a:latin typeface="Calibri" pitchFamily="34" charset="0"/>
                 <a:ea typeface="Calibri" pitchFamily="34" charset="-122"/>
@@ -2202,11 +2258,11 @@
             <a:avLst/>
           </a:prstGeom>
           <a:solidFill>
-            <a:srgbClr val="F4ECD8"/>
+            <a:srgbClr val="F9E8EE"/>
           </a:solidFill>
           <a:ln w="12700">
             <a:solidFill>
-              <a:srgbClr val="F4ECD8"/>
+              <a:srgbClr val="F9E8EE"/>
             </a:solidFill>
             <a:prstDash val="solid"/>
           </a:ln>
@@ -2263,7 +2319,7 @@
             <a:r>
               <a:rPr lang="en-US" sz="1500" dirty="0">
                 <a:solidFill>
-                  <a:srgbClr val="1B2733"/>
+                  <a:srgbClr val="221A1D"/>
                 </a:solidFill>
                 <a:latin typeface="Calibri" pitchFamily="34" charset="0"/>
                 <a:ea typeface="Calibri" pitchFamily="34" charset="-122"/>
@@ -2290,11 +2346,11 @@
             <a:avLst/>
           </a:prstGeom>
           <a:solidFill>
-            <a:srgbClr val="F4ECD8"/>
+            <a:srgbClr val="F9E8EE"/>
           </a:solidFill>
           <a:ln w="12700">
             <a:solidFill>
-              <a:srgbClr val="F4ECD8"/>
+              <a:srgbClr val="F9E8EE"/>
             </a:solidFill>
             <a:prstDash val="solid"/>
           </a:ln>
@@ -2351,7 +2407,7 @@
             <a:r>
               <a:rPr lang="en-US" sz="1500" dirty="0">
                 <a:solidFill>
-                  <a:srgbClr val="1B2733"/>
+                  <a:srgbClr val="221A1D"/>
                 </a:solidFill>
                 <a:latin typeface="Calibri" pitchFamily="34" charset="0"/>
                 <a:ea typeface="Calibri" pitchFamily="34" charset="-122"/>
@@ -2378,11 +2434,11 @@
             <a:avLst/>
           </a:prstGeom>
           <a:solidFill>
-            <a:srgbClr val="F4ECD8"/>
+            <a:srgbClr val="F9E8EE"/>
           </a:solidFill>
           <a:ln w="12700">
             <a:solidFill>
-              <a:srgbClr val="F4ECD8"/>
+              <a:srgbClr val="F9E8EE"/>
             </a:solidFill>
             <a:prstDash val="solid"/>
           </a:ln>
@@ -2439,7 +2495,7 @@
             <a:r>
               <a:rPr lang="en-US" sz="1500" dirty="0">
                 <a:solidFill>
-                  <a:srgbClr val="1B2733"/>
+                  <a:srgbClr val="221A1D"/>
                 </a:solidFill>
                 <a:latin typeface="Calibri" pitchFamily="34" charset="0"/>
                 <a:ea typeface="Calibri" pitchFamily="34" charset="-122"/>
@@ -2468,11 +2524,11 @@
             </a:avLst>
           </a:prstGeom>
           <a:solidFill>
-            <a:srgbClr val="0B1F33"/>
+            <a:srgbClr val="4A0F26"/>
           </a:solidFill>
           <a:ln w="12700">
             <a:solidFill>
-              <a:srgbClr val="0B1F33"/>
+              <a:srgbClr val="4A0F26"/>
             </a:solidFill>
             <a:prstDash val="solid"/>
           </a:ln>
@@ -2555,7 +2611,7 @@
     <p:bg>
       <p:bgPr>
         <a:solidFill>
-          <a:srgbClr val="F4F6F9"/>
+          <a:srgbClr val="F6F4F5"/>
         </a:solidFill>
       </p:bgPr>
     </p:bg>
@@ -2589,8 +2645,8 @@
         </p:blipFill>
         <p:spPr>
           <a:xfrm>
-            <a:off x="7452360" y="274320"/>
-            <a:ext cx="1325880" cy="414337"/>
+            <a:off x="8211312" y="182880"/>
+            <a:ext cx="566928" cy="566928"/>
           </a:xfrm>
           <a:prstGeom prst="rect">
             <a:avLst/>
@@ -2624,7 +2680,7 @@
             <a:r>
               <a:rPr lang="en-US" sz="1000" b="1" spc="400" kern="0" dirty="0">
                 <a:solidFill>
-                  <a:srgbClr val="C8A04A"/>
+                  <a:srgbClr val="B8315A"/>
                 </a:solidFill>
                 <a:latin typeface="Arial" pitchFamily="34" charset="0"/>
                 <a:ea typeface="Arial" pitchFamily="34" charset="-122"/>
@@ -2663,7 +2719,7 @@
             <a:r>
               <a:rPr lang="en-US" sz="800" spc="300" kern="0" dirty="0">
                 <a:solidFill>
-                  <a:srgbClr val="8A94A1"/>
+                  <a:srgbClr val="9A8C92"/>
                 </a:solidFill>
                 <a:latin typeface="Arial" pitchFamily="34" charset="0"/>
                 <a:ea typeface="Arial" pitchFamily="34" charset="-122"/>
@@ -2702,7 +2758,7 @@
             <a:r>
               <a:rPr lang="en-US" sz="800" dirty="0">
                 <a:solidFill>
-                  <a:srgbClr val="8A94A1"/>
+                  <a:srgbClr val="9A8C92"/>
                 </a:solidFill>
                 <a:latin typeface="Arial" pitchFamily="34" charset="0"/>
                 <a:ea typeface="Arial" pitchFamily="34" charset="-122"/>
@@ -2741,7 +2797,7 @@
             <a:r>
               <a:rPr lang="en-US" sz="3000" b="1" dirty="0">
                 <a:solidFill>
-                  <a:srgbClr val="0B1F33"/>
+                  <a:srgbClr val="4A0F26"/>
                 </a:solidFill>
                 <a:latin typeface="Arial" pitchFamily="34" charset="0"/>
                 <a:ea typeface="Arial" pitchFamily="34" charset="-122"/>
@@ -2780,7 +2836,7 @@
           </a:ln>
           <a:effectLst>
             <a:outerShdw sx="100000" sy="100000" kx="0" ky="0" algn="bl" rotWithShape="0" blurRad="152400" dist="38100" dir="5400000">
-              <a:srgbClr val="0B1F33">
+              <a:srgbClr val="4A0F26">
                 <a:alpha val="12000"/>
               </a:srgbClr>
             </a:outerShdw>
@@ -2802,11 +2858,11 @@
             <a:avLst/>
           </a:prstGeom>
           <a:solidFill>
-            <a:srgbClr val="0B1F33"/>
+            <a:srgbClr val="4A0F26"/>
           </a:solidFill>
           <a:ln w="12700">
             <a:solidFill>
-              <a:srgbClr val="0B1F33"/>
+              <a:srgbClr val="4A0F26"/>
             </a:solidFill>
             <a:prstDash val="solid"/>
           </a:ln>
@@ -2863,7 +2919,7 @@
             <a:r>
               <a:rPr lang="en-US" sz="1400" b="1" dirty="0">
                 <a:solidFill>
-                  <a:srgbClr val="0B1F33"/>
+                  <a:srgbClr val="4A0F26"/>
                 </a:solidFill>
                 <a:latin typeface="Arial" pitchFamily="34" charset="0"/>
                 <a:ea typeface="Arial" pitchFamily="34" charset="-122"/>
@@ -2902,7 +2958,7 @@
             <a:r>
               <a:rPr lang="en-US" sz="1300" dirty="0">
                 <a:solidFill>
-                  <a:srgbClr val="5F6B7A"/>
+                  <a:srgbClr val="6B6166"/>
                 </a:solidFill>
                 <a:latin typeface="Calibri" pitchFamily="34" charset="0"/>
                 <a:ea typeface="Calibri" pitchFamily="34" charset="-122"/>
@@ -2941,7 +2997,7 @@
           </a:ln>
           <a:effectLst>
             <a:outerShdw sx="100000" sy="100000" kx="0" ky="0" algn="bl" rotWithShape="0" blurRad="152400" dist="38100" dir="5400000">
-              <a:srgbClr val="0B1F33">
+              <a:srgbClr val="4A0F26">
                 <a:alpha val="12000"/>
               </a:srgbClr>
             </a:outerShdw>
@@ -2963,11 +3019,11 @@
             <a:avLst/>
           </a:prstGeom>
           <a:solidFill>
-            <a:srgbClr val="0B1F33"/>
+            <a:srgbClr val="4A0F26"/>
           </a:solidFill>
           <a:ln w="12700">
             <a:solidFill>
-              <a:srgbClr val="0B1F33"/>
+              <a:srgbClr val="4A0F26"/>
             </a:solidFill>
             <a:prstDash val="solid"/>
           </a:ln>
@@ -3024,7 +3080,7 @@
             <a:r>
               <a:rPr lang="en-US" sz="1400" b="1" dirty="0">
                 <a:solidFill>
-                  <a:srgbClr val="0B1F33"/>
+                  <a:srgbClr val="4A0F26"/>
                 </a:solidFill>
                 <a:latin typeface="Arial" pitchFamily="34" charset="0"/>
                 <a:ea typeface="Arial" pitchFamily="34" charset="-122"/>
@@ -3063,7 +3119,7 @@
             <a:r>
               <a:rPr lang="en-US" sz="1300" dirty="0">
                 <a:solidFill>
-                  <a:srgbClr val="5F6B7A"/>
+                  <a:srgbClr val="6B6166"/>
                 </a:solidFill>
                 <a:latin typeface="Calibri" pitchFamily="34" charset="0"/>
                 <a:ea typeface="Calibri" pitchFamily="34" charset="-122"/>
@@ -3102,7 +3158,7 @@
           </a:ln>
           <a:effectLst>
             <a:outerShdw sx="100000" sy="100000" kx="0" ky="0" algn="bl" rotWithShape="0" blurRad="152400" dist="38100" dir="5400000">
-              <a:srgbClr val="0B1F33">
+              <a:srgbClr val="4A0F26">
                 <a:alpha val="12000"/>
               </a:srgbClr>
             </a:outerShdw>
@@ -3124,11 +3180,11 @@
             <a:avLst/>
           </a:prstGeom>
           <a:solidFill>
-            <a:srgbClr val="0B1F33"/>
+            <a:srgbClr val="4A0F26"/>
           </a:solidFill>
           <a:ln w="12700">
             <a:solidFill>
-              <a:srgbClr val="0B1F33"/>
+              <a:srgbClr val="4A0F26"/>
             </a:solidFill>
             <a:prstDash val="solid"/>
           </a:ln>
@@ -3185,7 +3241,7 @@
             <a:r>
               <a:rPr lang="en-US" sz="1400" b="1" dirty="0">
                 <a:solidFill>
-                  <a:srgbClr val="0B1F33"/>
+                  <a:srgbClr val="4A0F26"/>
                 </a:solidFill>
                 <a:latin typeface="Arial" pitchFamily="34" charset="0"/>
                 <a:ea typeface="Arial" pitchFamily="34" charset="-122"/>
@@ -3224,7 +3280,7 @@
             <a:r>
               <a:rPr lang="en-US" sz="1300" dirty="0">
                 <a:solidFill>
-                  <a:srgbClr val="5F6B7A"/>
+                  <a:srgbClr val="6B6166"/>
                 </a:solidFill>
                 <a:latin typeface="Calibri" pitchFamily="34" charset="0"/>
                 <a:ea typeface="Calibri" pitchFamily="34" charset="-122"/>
@@ -3263,7 +3319,7 @@
           </a:ln>
           <a:effectLst>
             <a:outerShdw sx="100000" sy="100000" kx="0" ky="0" algn="bl" rotWithShape="0" blurRad="152400" dist="38100" dir="5400000">
-              <a:srgbClr val="0B1F33">
+              <a:srgbClr val="4A0F26">
                 <a:alpha val="12000"/>
               </a:srgbClr>
             </a:outerShdw>
@@ -3285,11 +3341,11 @@
             <a:avLst/>
           </a:prstGeom>
           <a:solidFill>
-            <a:srgbClr val="0B1F33"/>
+            <a:srgbClr val="4A0F26"/>
           </a:solidFill>
           <a:ln w="12700">
             <a:solidFill>
-              <a:srgbClr val="0B1F33"/>
+              <a:srgbClr val="4A0F26"/>
             </a:solidFill>
             <a:prstDash val="solid"/>
           </a:ln>
@@ -3346,7 +3402,7 @@
             <a:r>
               <a:rPr lang="en-US" sz="1400" b="1" dirty="0">
                 <a:solidFill>
-                  <a:srgbClr val="0B1F33"/>
+                  <a:srgbClr val="4A0F26"/>
                 </a:solidFill>
                 <a:latin typeface="Arial" pitchFamily="34" charset="0"/>
                 <a:ea typeface="Arial" pitchFamily="34" charset="-122"/>
@@ -3385,7 +3441,7 @@
             <a:r>
               <a:rPr lang="en-US" sz="1300" dirty="0">
                 <a:solidFill>
-                  <a:srgbClr val="5F6B7A"/>
+                  <a:srgbClr val="6B6166"/>
                 </a:solidFill>
                 <a:latin typeface="Calibri" pitchFamily="34" charset="0"/>
                 <a:ea typeface="Calibri" pitchFamily="34" charset="-122"/>
@@ -3414,17 +3470,17 @@
             </a:avLst>
           </a:prstGeom>
           <a:solidFill>
-            <a:srgbClr val="0B1F33"/>
+            <a:srgbClr val="4A0F26"/>
           </a:solidFill>
           <a:ln w="12700">
             <a:solidFill>
-              <a:srgbClr val="0B1F33"/>
+              <a:srgbClr val="4A0F26"/>
             </a:solidFill>
             <a:prstDash val="solid"/>
           </a:ln>
           <a:effectLst>
             <a:outerShdw sx="100000" sy="100000" kx="0" ky="0" algn="bl" rotWithShape="0" blurRad="152400" dist="38100" dir="5400000">
-              <a:srgbClr val="0B1F33">
+              <a:srgbClr val="4A0F26">
                 <a:alpha val="12000"/>
               </a:srgbClr>
             </a:outerShdw>
@@ -3521,7 +3577,7 @@
             <a:r>
               <a:rPr lang="en-US" sz="900" b="1" spc="400" kern="0" dirty="0">
                 <a:solidFill>
-                  <a:srgbClr val="C8A04A"/>
+                  <a:srgbClr val="D6D9DE"/>
                 </a:solidFill>
                 <a:latin typeface="Arial" pitchFamily="34" charset="0"/>
                 <a:ea typeface="Arial" pitchFamily="34" charset="-122"/>
@@ -3581,8 +3637,8 @@
         </p:blipFill>
         <p:spPr>
           <a:xfrm>
-            <a:off x="7452360" y="274320"/>
-            <a:ext cx="1325880" cy="414337"/>
+            <a:off x="8211312" y="182880"/>
+            <a:ext cx="566928" cy="566928"/>
           </a:xfrm>
           <a:prstGeom prst="rect">
             <a:avLst/>
@@ -3616,7 +3672,7 @@
             <a:r>
               <a:rPr lang="en-US" sz="1000" b="1" spc="400" kern="0" dirty="0">
                 <a:solidFill>
-                  <a:srgbClr val="C8A04A"/>
+                  <a:srgbClr val="B8315A"/>
                 </a:solidFill>
                 <a:latin typeface="Arial" pitchFamily="34" charset="0"/>
                 <a:ea typeface="Arial" pitchFamily="34" charset="-122"/>
@@ -3655,7 +3711,7 @@
             <a:r>
               <a:rPr lang="en-US" sz="800" spc="300" kern="0" dirty="0">
                 <a:solidFill>
-                  <a:srgbClr val="8A94A1"/>
+                  <a:srgbClr val="9A8C92"/>
                 </a:solidFill>
                 <a:latin typeface="Arial" pitchFamily="34" charset="0"/>
                 <a:ea typeface="Arial" pitchFamily="34" charset="-122"/>
@@ -3694,7 +3750,7 @@
             <a:r>
               <a:rPr lang="en-US" sz="800" dirty="0">
                 <a:solidFill>
-                  <a:srgbClr val="8A94A1"/>
+                  <a:srgbClr val="9A8C92"/>
                 </a:solidFill>
                 <a:latin typeface="Arial" pitchFamily="34" charset="0"/>
                 <a:ea typeface="Arial" pitchFamily="34" charset="-122"/>
@@ -3733,7 +3789,7 @@
             <a:r>
               <a:rPr lang="en-US" sz="2800" b="1" dirty="0">
                 <a:solidFill>
-                  <a:srgbClr val="0B1F33"/>
+                  <a:srgbClr val="4A0F26"/>
                 </a:solidFill>
                 <a:latin typeface="Arial" pitchFamily="34" charset="0"/>
                 <a:ea typeface="Arial" pitchFamily="34" charset="-122"/>
@@ -3747,7 +3803,7 @@
             <a:r>
               <a:rPr lang="en-US" sz="2800" b="1" dirty="0">
                 <a:solidFill>
-                  <a:srgbClr val="0B1F33"/>
+                  <a:srgbClr val="4A0F26"/>
                 </a:solidFill>
                 <a:latin typeface="Arial" pitchFamily="34" charset="0"/>
                 <a:ea typeface="Arial" pitchFamily="34" charset="-122"/>
@@ -3761,7 +3817,7 @@
             <a:r>
               <a:rPr lang="en-US" sz="2800" b="1" dirty="0">
                 <a:solidFill>
-                  <a:srgbClr val="C8A04A"/>
+                  <a:srgbClr val="B8315A"/>
                 </a:solidFill>
                 <a:latin typeface="Arial" pitchFamily="34" charset="0"/>
                 <a:ea typeface="Arial" pitchFamily="34" charset="-122"/>
@@ -3790,7 +3846,7 @@
           <a:noFill/>
           <a:ln w="19050">
             <a:solidFill>
-              <a:srgbClr val="D9C38F"/>
+              <a:srgbClr val="E3A5B8"/>
             </a:solidFill>
             <a:prstDash val="dash"/>
           </a:ln>
@@ -3811,11 +3867,11 @@
             <a:avLst/>
           </a:prstGeom>
           <a:solidFill>
-            <a:srgbClr val="0B1F33"/>
+            <a:srgbClr val="4A0F26"/>
           </a:solidFill>
           <a:ln w="12700">
             <a:solidFill>
-              <a:srgbClr val="0B1F33"/>
+              <a:srgbClr val="4A0F26"/>
             </a:solidFill>
             <a:prstDash val="solid"/>
           </a:ln>
@@ -3872,7 +3928,7 @@
             <a:r>
               <a:rPr lang="en-US" sz="900" b="1" spc="300" kern="0" dirty="0">
                 <a:solidFill>
-                  <a:srgbClr val="C8A04A"/>
+                  <a:srgbClr val="B8315A"/>
                 </a:solidFill>
                 <a:latin typeface="Arial" pitchFamily="34" charset="0"/>
                 <a:ea typeface="Arial" pitchFamily="34" charset="-122"/>
@@ -3911,7 +3967,7 @@
             <a:r>
               <a:rPr lang="en-US" sz="1500" b="1" dirty="0">
                 <a:solidFill>
-                  <a:srgbClr val="0B1F33"/>
+                  <a:srgbClr val="4A0F26"/>
                 </a:solidFill>
                 <a:latin typeface="Arial" pitchFamily="34" charset="0"/>
                 <a:ea typeface="Arial" pitchFamily="34" charset="-122"/>
@@ -3950,7 +4006,7 @@
             <a:r>
               <a:rPr lang="en-US" sz="1300" dirty="0">
                 <a:solidFill>
-                  <a:srgbClr val="5F6B7A"/>
+                  <a:srgbClr val="6B6166"/>
                 </a:solidFill>
                 <a:latin typeface="Calibri" pitchFamily="34" charset="0"/>
                 <a:ea typeface="Calibri" pitchFamily="34" charset="-122"/>
@@ -3977,11 +4033,11 @@
             <a:avLst/>
           </a:prstGeom>
           <a:solidFill>
-            <a:srgbClr val="0B1F33"/>
+            <a:srgbClr val="4A0F26"/>
           </a:solidFill>
           <a:ln w="12700">
             <a:solidFill>
-              <a:srgbClr val="0B1F33"/>
+              <a:srgbClr val="4A0F26"/>
             </a:solidFill>
             <a:prstDash val="solid"/>
           </a:ln>
@@ -4038,7 +4094,7 @@
             <a:r>
               <a:rPr lang="en-US" sz="900" b="1" spc="300" kern="0" dirty="0">
                 <a:solidFill>
-                  <a:srgbClr val="C8A04A"/>
+                  <a:srgbClr val="B8315A"/>
                 </a:solidFill>
                 <a:latin typeface="Arial" pitchFamily="34" charset="0"/>
                 <a:ea typeface="Arial" pitchFamily="34" charset="-122"/>
@@ -4077,7 +4133,7 @@
             <a:r>
               <a:rPr lang="en-US" sz="1500" b="1" dirty="0">
                 <a:solidFill>
-                  <a:srgbClr val="0B1F33"/>
+                  <a:srgbClr val="4A0F26"/>
                 </a:solidFill>
                 <a:latin typeface="Arial" pitchFamily="34" charset="0"/>
                 <a:ea typeface="Arial" pitchFamily="34" charset="-122"/>
@@ -4116,7 +4172,7 @@
             <a:r>
               <a:rPr lang="en-US" sz="1300" dirty="0">
                 <a:solidFill>
-                  <a:srgbClr val="5F6B7A"/>
+                  <a:srgbClr val="6B6166"/>
                 </a:solidFill>
                 <a:latin typeface="Calibri" pitchFamily="34" charset="0"/>
                 <a:ea typeface="Calibri" pitchFamily="34" charset="-122"/>
@@ -4143,11 +4199,11 @@
             <a:avLst/>
           </a:prstGeom>
           <a:solidFill>
-            <a:srgbClr val="0B1F33"/>
+            <a:srgbClr val="4A0F26"/>
           </a:solidFill>
           <a:ln w="12700">
             <a:solidFill>
-              <a:srgbClr val="0B1F33"/>
+              <a:srgbClr val="4A0F26"/>
             </a:solidFill>
             <a:prstDash val="solid"/>
           </a:ln>
@@ -4204,7 +4260,7 @@
             <a:r>
               <a:rPr lang="en-US" sz="900" b="1" spc="300" kern="0" dirty="0">
                 <a:solidFill>
-                  <a:srgbClr val="C8A04A"/>
+                  <a:srgbClr val="B8315A"/>
                 </a:solidFill>
                 <a:latin typeface="Arial" pitchFamily="34" charset="0"/>
                 <a:ea typeface="Arial" pitchFamily="34" charset="-122"/>
@@ -4243,7 +4299,7 @@
             <a:r>
               <a:rPr lang="en-US" sz="1500" b="1" dirty="0">
                 <a:solidFill>
-                  <a:srgbClr val="0B1F33"/>
+                  <a:srgbClr val="4A0F26"/>
                 </a:solidFill>
                 <a:latin typeface="Arial" pitchFamily="34" charset="0"/>
                 <a:ea typeface="Arial" pitchFamily="34" charset="-122"/>
@@ -4282,7 +4338,7 @@
             <a:r>
               <a:rPr lang="en-US" sz="1300" dirty="0">
                 <a:solidFill>
-                  <a:srgbClr val="5F6B7A"/>
+                  <a:srgbClr val="6B6166"/>
                 </a:solidFill>
                 <a:latin typeface="Calibri" pitchFamily="34" charset="0"/>
                 <a:ea typeface="Calibri" pitchFamily="34" charset="-122"/>
@@ -4309,11 +4365,11 @@
             <a:avLst/>
           </a:prstGeom>
           <a:solidFill>
-            <a:srgbClr val="0B1F33"/>
+            <a:srgbClr val="4A0F26"/>
           </a:solidFill>
           <a:ln w="12700">
             <a:solidFill>
-              <a:srgbClr val="0B1F33"/>
+              <a:srgbClr val="4A0F26"/>
             </a:solidFill>
             <a:prstDash val="solid"/>
           </a:ln>
@@ -4370,7 +4426,7 @@
             <a:r>
               <a:rPr lang="en-US" sz="900" b="1" spc="300" kern="0" dirty="0">
                 <a:solidFill>
-                  <a:srgbClr val="C8A04A"/>
+                  <a:srgbClr val="B8315A"/>
                 </a:solidFill>
                 <a:latin typeface="Arial" pitchFamily="34" charset="0"/>
                 <a:ea typeface="Arial" pitchFamily="34" charset="-122"/>
@@ -4409,7 +4465,7 @@
             <a:r>
               <a:rPr lang="en-US" sz="1500" b="1" dirty="0">
                 <a:solidFill>
-                  <a:srgbClr val="0B1F33"/>
+                  <a:srgbClr val="4A0F26"/>
                 </a:solidFill>
                 <a:latin typeface="Arial" pitchFamily="34" charset="0"/>
                 <a:ea typeface="Arial" pitchFamily="34" charset="-122"/>
@@ -4448,7 +4504,7 @@
             <a:r>
               <a:rPr lang="en-US" sz="1300" dirty="0">
                 <a:solidFill>
-                  <a:srgbClr val="5F6B7A"/>
+                  <a:srgbClr val="6B6166"/>
                 </a:solidFill>
                 <a:latin typeface="Calibri" pitchFamily="34" charset="0"/>
                 <a:ea typeface="Calibri" pitchFamily="34" charset="-122"/>
@@ -4477,11 +4533,11 @@
             </a:avLst>
           </a:prstGeom>
           <a:solidFill>
-            <a:srgbClr val="F4ECD8"/>
+            <a:srgbClr val="F9E8EE"/>
           </a:solidFill>
           <a:ln w="12700">
             <a:solidFill>
-              <a:srgbClr val="F4ECD8"/>
+              <a:srgbClr val="F9E8EE"/>
             </a:solidFill>
             <a:prstDash val="solid"/>
           </a:ln>
@@ -4538,7 +4594,7 @@
             <a:r>
               <a:rPr lang="en-US" sz="1800" i="1" dirty="0">
                 <a:solidFill>
-                  <a:srgbClr val="0B1F33"/>
+                  <a:srgbClr val="4A0F26"/>
                 </a:solidFill>
                 <a:latin typeface="Cambria" pitchFamily="34" charset="0"/>
                 <a:ea typeface="Cambria" pitchFamily="34" charset="-122"/>
@@ -4605,8 +4661,8 @@
         </p:blipFill>
         <p:spPr>
           <a:xfrm>
-            <a:off x="7452360" y="274320"/>
-            <a:ext cx="1325880" cy="414337"/>
+            <a:off x="8211312" y="182880"/>
+            <a:ext cx="566928" cy="566928"/>
           </a:xfrm>
           <a:prstGeom prst="rect">
             <a:avLst/>
@@ -4640,7 +4696,7 @@
             <a:r>
               <a:rPr lang="en-US" sz="1000" b="1" spc="400" kern="0" dirty="0">
                 <a:solidFill>
-                  <a:srgbClr val="C8A04A"/>
+                  <a:srgbClr val="D6D9DE"/>
                 </a:solidFill>
                 <a:latin typeface="Arial" pitchFamily="34" charset="0"/>
                 <a:ea typeface="Arial" pitchFamily="34" charset="-122"/>
@@ -4679,7 +4735,7 @@
             <a:r>
               <a:rPr lang="en-US" sz="800" spc="300" kern="0" dirty="0">
                 <a:solidFill>
-                  <a:srgbClr val="8FA3B8"/>
+                  <a:srgbClr val="D2B3BF"/>
                 </a:solidFill>
                 <a:latin typeface="Arial" pitchFamily="34" charset="0"/>
                 <a:ea typeface="Arial" pitchFamily="34" charset="-122"/>
@@ -4718,7 +4774,7 @@
             <a:r>
               <a:rPr lang="en-US" sz="800" dirty="0">
                 <a:solidFill>
-                  <a:srgbClr val="8FA3B8"/>
+                  <a:srgbClr val="D2B3BF"/>
                 </a:solidFill>
                 <a:latin typeface="Arial" pitchFamily="34" charset="0"/>
                 <a:ea typeface="Arial" pitchFamily="34" charset="-122"/>
@@ -4792,7 +4848,7 @@
           </a:solidFill>
           <a:ln w="9525">
             <a:solidFill>
-              <a:srgbClr val="3A5776"/>
+              <a:srgbClr val="9C5670"/>
             </a:solidFill>
             <a:prstDash val="solid"/>
           </a:ln>
@@ -4813,11 +4869,11 @@
             <a:avLst/>
           </a:prstGeom>
           <a:solidFill>
-            <a:srgbClr val="C8A04A"/>
+            <a:srgbClr val="D6D9DE"/>
           </a:solidFill>
           <a:ln w="12700">
             <a:solidFill>
-              <a:srgbClr val="C8A04A"/>
+              <a:srgbClr val="D6D9DE"/>
             </a:solidFill>
             <a:prstDash val="solid"/>
           </a:ln>
@@ -4909,7 +4965,7 @@
           </a:solidFill>
           <a:ln w="9525">
             <a:solidFill>
-              <a:srgbClr val="3A5776"/>
+              <a:srgbClr val="9C5670"/>
             </a:solidFill>
             <a:prstDash val="solid"/>
           </a:ln>
@@ -4930,11 +4986,11 @@
             <a:avLst/>
           </a:prstGeom>
           <a:solidFill>
-            <a:srgbClr val="C8A04A"/>
+            <a:srgbClr val="D6D9DE"/>
           </a:solidFill>
           <a:ln w="12700">
             <a:solidFill>
-              <a:srgbClr val="C8A04A"/>
+              <a:srgbClr val="D6D9DE"/>
             </a:solidFill>
             <a:prstDash val="solid"/>
           </a:ln>
@@ -5026,7 +5082,7 @@
           </a:solidFill>
           <a:ln w="9525">
             <a:solidFill>
-              <a:srgbClr val="3A5776"/>
+              <a:srgbClr val="9C5670"/>
             </a:solidFill>
             <a:prstDash val="solid"/>
           </a:ln>
@@ -5047,11 +5103,11 @@
             <a:avLst/>
           </a:prstGeom>
           <a:solidFill>
-            <a:srgbClr val="C8A04A"/>
+            <a:srgbClr val="D6D9DE"/>
           </a:solidFill>
           <a:ln w="12700">
             <a:solidFill>
-              <a:srgbClr val="C8A04A"/>
+              <a:srgbClr val="D6D9DE"/>
             </a:solidFill>
             <a:prstDash val="solid"/>
           </a:ln>
@@ -5143,7 +5199,7 @@
           </a:solidFill>
           <a:ln w="9525">
             <a:solidFill>
-              <a:srgbClr val="3A5776"/>
+              <a:srgbClr val="9C5670"/>
             </a:solidFill>
             <a:prstDash val="solid"/>
           </a:ln>
@@ -5164,11 +5220,11 @@
             <a:avLst/>
           </a:prstGeom>
           <a:solidFill>
-            <a:srgbClr val="C8A04A"/>
+            <a:srgbClr val="D6D9DE"/>
           </a:solidFill>
           <a:ln w="12700">
             <a:solidFill>
-              <a:srgbClr val="C8A04A"/>
+              <a:srgbClr val="D6D9DE"/>
             </a:solidFill>
             <a:prstDash val="solid"/>
           </a:ln>
@@ -5260,7 +5316,7 @@
           </a:solidFill>
           <a:ln w="9525">
             <a:solidFill>
-              <a:srgbClr val="3A5776"/>
+              <a:srgbClr val="9C5670"/>
             </a:solidFill>
             <a:prstDash val="solid"/>
           </a:ln>
@@ -5281,11 +5337,11 @@
             <a:avLst/>
           </a:prstGeom>
           <a:solidFill>
-            <a:srgbClr val="C8A04A"/>
+            <a:srgbClr val="D6D9DE"/>
           </a:solidFill>
           <a:ln w="12700">
             <a:solidFill>
-              <a:srgbClr val="C8A04A"/>
+              <a:srgbClr val="D6D9DE"/>
             </a:solidFill>
             <a:prstDash val="solid"/>
           </a:ln>
@@ -5405,7 +5461,7 @@
             <a:r>
               <a:rPr lang="en-US" sz="2000" i="1" dirty="0">
                 <a:solidFill>
-                  <a:srgbClr val="C8A04A"/>
+                  <a:srgbClr val="F2A7BD"/>
                 </a:solidFill>
                 <a:latin typeface="Cambria" pitchFamily="34" charset="0"/>
                 <a:ea typeface="Cambria" pitchFamily="34" charset="-122"/>
@@ -5465,8 +5521,8 @@
         </p:blipFill>
         <p:spPr>
           <a:xfrm>
-            <a:off x="7452360" y="274320"/>
-            <a:ext cx="1325880" cy="414337"/>
+            <a:off x="8211312" y="182880"/>
+            <a:ext cx="566928" cy="566928"/>
           </a:xfrm>
           <a:prstGeom prst="rect">
             <a:avLst/>
@@ -5500,7 +5556,7 @@
             <a:r>
               <a:rPr lang="en-US" sz="1000" b="1" spc="400" kern="0" dirty="0">
                 <a:solidFill>
-                  <a:srgbClr val="C8A04A"/>
+                  <a:srgbClr val="B8315A"/>
                 </a:solidFill>
                 <a:latin typeface="Arial" pitchFamily="34" charset="0"/>
                 <a:ea typeface="Arial" pitchFamily="34" charset="-122"/>
@@ -5539,7 +5595,7 @@
             <a:r>
               <a:rPr lang="en-US" sz="800" spc="300" kern="0" dirty="0">
                 <a:solidFill>
-                  <a:srgbClr val="8A94A1"/>
+                  <a:srgbClr val="9A8C92"/>
                 </a:solidFill>
                 <a:latin typeface="Arial" pitchFamily="34" charset="0"/>
                 <a:ea typeface="Arial" pitchFamily="34" charset="-122"/>
@@ -5578,7 +5634,7 @@
             <a:r>
               <a:rPr lang="en-US" sz="800" dirty="0">
                 <a:solidFill>
-                  <a:srgbClr val="8A94A1"/>
+                  <a:srgbClr val="9A8C92"/>
                 </a:solidFill>
                 <a:latin typeface="Arial" pitchFamily="34" charset="0"/>
                 <a:ea typeface="Arial" pitchFamily="34" charset="-122"/>
@@ -5617,7 +5673,7 @@
             <a:r>
               <a:rPr lang="en-US" sz="3200" b="1" dirty="0">
                 <a:solidFill>
-                  <a:srgbClr val="0B1F33"/>
+                  <a:srgbClr val="4A0F26"/>
                 </a:solidFill>
                 <a:latin typeface="Arial" pitchFamily="34" charset="0"/>
                 <a:ea typeface="Arial" pitchFamily="34" charset="-122"/>
@@ -5634,7 +5690,7 @@
             <a:r>
               <a:rPr lang="en-US" sz="3200" b="1" dirty="0">
                 <a:solidFill>
-                  <a:srgbClr val="0B1F33"/>
+                  <a:srgbClr val="4A0F26"/>
                 </a:solidFill>
                 <a:latin typeface="Arial" pitchFamily="34" charset="0"/>
                 <a:ea typeface="Arial" pitchFamily="34" charset="-122"/>
@@ -5663,17 +5719,17 @@
             </a:avLst>
           </a:prstGeom>
           <a:solidFill>
-            <a:srgbClr val="0B1F33"/>
+            <a:srgbClr val="4A0F26"/>
           </a:solidFill>
           <a:ln w="12700">
             <a:solidFill>
-              <a:srgbClr val="0B1F33"/>
+              <a:srgbClr val="4A0F26"/>
             </a:solidFill>
             <a:prstDash val="solid"/>
           </a:ln>
           <a:effectLst>
             <a:outerShdw sx="100000" sy="100000" kx="0" ky="0" algn="bl" rotWithShape="0" blurRad="152400" dist="38100" dir="5400000">
-              <a:srgbClr val="0B1F33">
+              <a:srgbClr val="4A0F26">
                 <a:alpha val="12000"/>
               </a:srgbClr>
             </a:outerShdw>
@@ -5758,11 +5814,11 @@
             <a:avLst/>
           </a:prstGeom>
           <a:solidFill>
-            <a:srgbClr val="F4ECD8"/>
+            <a:srgbClr val="F9E8EE"/>
           </a:solidFill>
           <a:ln w="12700">
             <a:solidFill>
-              <a:srgbClr val="F4ECD8"/>
+              <a:srgbClr val="F9E8EE"/>
             </a:solidFill>
             <a:prstDash val="solid"/>
           </a:ln>
@@ -5819,7 +5875,7 @@
             <a:r>
               <a:rPr lang="en-US" sz="1500" dirty="0">
                 <a:solidFill>
-                  <a:srgbClr val="1B2733"/>
+                  <a:srgbClr val="221A1D"/>
                 </a:solidFill>
                 <a:latin typeface="Calibri" pitchFamily="34" charset="0"/>
                 <a:ea typeface="Calibri" pitchFamily="34" charset="-122"/>
@@ -5869,11 +5925,11 @@
             <a:avLst/>
           </a:prstGeom>
           <a:solidFill>
-            <a:srgbClr val="F4ECD8"/>
+            <a:srgbClr val="F9E8EE"/>
           </a:solidFill>
           <a:ln w="12700">
             <a:solidFill>
-              <a:srgbClr val="F4ECD8"/>
+              <a:srgbClr val="F9E8EE"/>
             </a:solidFill>
             <a:prstDash val="solid"/>
           </a:ln>
@@ -5930,7 +5986,7 @@
             <a:r>
               <a:rPr lang="en-US" sz="1500" dirty="0">
                 <a:solidFill>
-                  <a:srgbClr val="1B2733"/>
+                  <a:srgbClr val="221A1D"/>
                 </a:solidFill>
                 <a:latin typeface="Calibri" pitchFamily="34" charset="0"/>
                 <a:ea typeface="Calibri" pitchFamily="34" charset="-122"/>
@@ -5980,11 +6036,11 @@
             <a:avLst/>
           </a:prstGeom>
           <a:solidFill>
-            <a:srgbClr val="F4ECD8"/>
+            <a:srgbClr val="F9E8EE"/>
           </a:solidFill>
           <a:ln w="12700">
             <a:solidFill>
-              <a:srgbClr val="F4ECD8"/>
+              <a:srgbClr val="F9E8EE"/>
             </a:solidFill>
             <a:prstDash val="solid"/>
           </a:ln>
@@ -6041,7 +6097,7 @@
             <a:r>
               <a:rPr lang="en-US" sz="1500" dirty="0">
                 <a:solidFill>
-                  <a:srgbClr val="1B2733"/>
+                  <a:srgbClr val="221A1D"/>
                 </a:solidFill>
                 <a:latin typeface="Calibri" pitchFamily="34" charset="0"/>
                 <a:ea typeface="Calibri" pitchFamily="34" charset="-122"/>
@@ -6091,11 +6147,11 @@
             <a:avLst/>
           </a:prstGeom>
           <a:solidFill>
-            <a:srgbClr val="F4ECD8"/>
+            <a:srgbClr val="F9E8EE"/>
           </a:solidFill>
           <a:ln w="12700">
             <a:solidFill>
-              <a:srgbClr val="F4ECD8"/>
+              <a:srgbClr val="F9E8EE"/>
             </a:solidFill>
             <a:prstDash val="solid"/>
           </a:ln>
@@ -6152,7 +6208,7 @@
             <a:r>
               <a:rPr lang="en-US" sz="1500" dirty="0">
                 <a:solidFill>
-                  <a:srgbClr val="1B2733"/>
+                  <a:srgbClr val="221A1D"/>
                 </a:solidFill>
                 <a:latin typeface="Calibri" pitchFamily="34" charset="0"/>
                 <a:ea typeface="Calibri" pitchFamily="34" charset="-122"/>
@@ -6202,11 +6258,11 @@
             <a:avLst/>
           </a:prstGeom>
           <a:solidFill>
-            <a:srgbClr val="F4ECD8"/>
+            <a:srgbClr val="F9E8EE"/>
           </a:solidFill>
           <a:ln w="12700">
             <a:solidFill>
-              <a:srgbClr val="F4ECD8"/>
+              <a:srgbClr val="F9E8EE"/>
             </a:solidFill>
             <a:prstDash val="solid"/>
           </a:ln>
@@ -6263,7 +6319,7 @@
             <a:r>
               <a:rPr lang="en-US" sz="1500" dirty="0">
                 <a:solidFill>
-                  <a:srgbClr val="1B2733"/>
+                  <a:srgbClr val="221A1D"/>
                 </a:solidFill>
                 <a:latin typeface="Calibri" pitchFamily="34" charset="0"/>
                 <a:ea typeface="Calibri" pitchFamily="34" charset="-122"/>
@@ -6289,7 +6345,7 @@
     <p:bg>
       <p:bgPr>
         <a:solidFill>
-          <a:srgbClr val="F4F6F9"/>
+          <a:srgbClr val="F6F4F5"/>
         </a:solidFill>
       </p:bgPr>
     </p:bg>
@@ -6346,8 +6402,8 @@
         </p:blipFill>
         <p:spPr>
           <a:xfrm>
-            <a:off x="7452360" y="274320"/>
-            <a:ext cx="1325880" cy="414337"/>
+            <a:off x="8211312" y="182880"/>
+            <a:ext cx="566928" cy="566928"/>
           </a:xfrm>
           <a:prstGeom prst="rect">
             <a:avLst/>
@@ -6381,7 +6437,7 @@
             <a:r>
               <a:rPr lang="en-US" sz="1000" b="1" spc="400" kern="0" dirty="0">
                 <a:solidFill>
-                  <a:srgbClr val="C8A04A"/>
+                  <a:srgbClr val="B8315A"/>
                 </a:solidFill>
                 <a:latin typeface="Arial" pitchFamily="34" charset="0"/>
                 <a:ea typeface="Arial" pitchFamily="34" charset="-122"/>
@@ -6420,7 +6476,7 @@
             <a:r>
               <a:rPr lang="en-US" sz="800" spc="300" kern="0" dirty="0">
                 <a:solidFill>
-                  <a:srgbClr val="8A94A1"/>
+                  <a:srgbClr val="9A8C92"/>
                 </a:solidFill>
                 <a:latin typeface="Arial" pitchFamily="34" charset="0"/>
                 <a:ea typeface="Arial" pitchFamily="34" charset="-122"/>
@@ -6459,7 +6515,7 @@
             <a:r>
               <a:rPr lang="en-US" sz="800" dirty="0">
                 <a:solidFill>
-                  <a:srgbClr val="8FA3B8"/>
+                  <a:srgbClr val="D2B3BF"/>
                 </a:solidFill>
                 <a:latin typeface="Arial" pitchFamily="34" charset="0"/>
                 <a:ea typeface="Arial" pitchFamily="34" charset="-122"/>
@@ -6498,7 +6554,7 @@
             <a:r>
               <a:rPr lang="en-US" sz="2800" b="1" dirty="0">
                 <a:solidFill>
-                  <a:srgbClr val="0B1F33"/>
+                  <a:srgbClr val="4A0F26"/>
                 </a:solidFill>
                 <a:latin typeface="Arial" pitchFamily="34" charset="0"/>
                 <a:ea typeface="Arial" pitchFamily="34" charset="-122"/>
@@ -6515,7 +6571,7 @@
             <a:r>
               <a:rPr lang="en-US" sz="2800" b="1" dirty="0">
                 <a:solidFill>
-                  <a:srgbClr val="0B1F33"/>
+                  <a:srgbClr val="4A0F26"/>
                 </a:solidFill>
                 <a:latin typeface="Arial" pitchFamily="34" charset="0"/>
                 <a:ea typeface="Arial" pitchFamily="34" charset="-122"/>
@@ -6554,7 +6610,7 @@
             <a:r>
               <a:rPr lang="en-US" sz="1800" b="1" dirty="0">
                 <a:solidFill>
-                  <a:srgbClr val="C8A04A"/>
+                  <a:srgbClr val="B8315A"/>
                 </a:solidFill>
                 <a:latin typeface="Arial" pitchFamily="34" charset="0"/>
                 <a:ea typeface="Arial" pitchFamily="34" charset="-122"/>
@@ -6593,7 +6649,7 @@
             <a:r>
               <a:rPr lang="en-US" sz="1500" dirty="0">
                 <a:solidFill>
-                  <a:srgbClr val="1B2733"/>
+                  <a:srgbClr val="221A1D"/>
                 </a:solidFill>
                 <a:latin typeface="Calibri" pitchFamily="34" charset="0"/>
                 <a:ea typeface="Calibri" pitchFamily="34" charset="-122"/>
@@ -6632,7 +6688,7 @@
             <a:r>
               <a:rPr lang="en-US" sz="1800" b="1" dirty="0">
                 <a:solidFill>
-                  <a:srgbClr val="C8A04A"/>
+                  <a:srgbClr val="B8315A"/>
                 </a:solidFill>
                 <a:latin typeface="Arial" pitchFamily="34" charset="0"/>
                 <a:ea typeface="Arial" pitchFamily="34" charset="-122"/>
@@ -6671,7 +6727,7 @@
             <a:r>
               <a:rPr lang="en-US" sz="1500" dirty="0">
                 <a:solidFill>
-                  <a:srgbClr val="1B2733"/>
+                  <a:srgbClr val="221A1D"/>
                 </a:solidFill>
                 <a:latin typeface="Calibri" pitchFamily="34" charset="0"/>
                 <a:ea typeface="Calibri" pitchFamily="34" charset="-122"/>
@@ -6710,7 +6766,7 @@
             <a:r>
               <a:rPr lang="en-US" sz="1800" b="1" dirty="0">
                 <a:solidFill>
-                  <a:srgbClr val="C8A04A"/>
+                  <a:srgbClr val="B8315A"/>
                 </a:solidFill>
                 <a:latin typeface="Arial" pitchFamily="34" charset="0"/>
                 <a:ea typeface="Arial" pitchFamily="34" charset="-122"/>
@@ -6749,7 +6805,7 @@
             <a:r>
               <a:rPr lang="en-US" sz="1500" dirty="0">
                 <a:solidFill>
-                  <a:srgbClr val="1B2733"/>
+                  <a:srgbClr val="221A1D"/>
                 </a:solidFill>
                 <a:latin typeface="Calibri" pitchFamily="34" charset="0"/>
                 <a:ea typeface="Calibri" pitchFamily="34" charset="-122"/>
@@ -6788,7 +6844,7 @@
             <a:r>
               <a:rPr lang="en-US" sz="1800" b="1" dirty="0">
                 <a:solidFill>
-                  <a:srgbClr val="C8A04A"/>
+                  <a:srgbClr val="B8315A"/>
                 </a:solidFill>
                 <a:latin typeface="Arial" pitchFamily="34" charset="0"/>
                 <a:ea typeface="Arial" pitchFamily="34" charset="-122"/>
@@ -6827,7 +6883,7 @@
             <a:r>
               <a:rPr lang="en-US" sz="1500" dirty="0">
                 <a:solidFill>
-                  <a:srgbClr val="1B2733"/>
+                  <a:srgbClr val="221A1D"/>
                 </a:solidFill>
                 <a:latin typeface="Calibri" pitchFamily="34" charset="0"/>
                 <a:ea typeface="Calibri" pitchFamily="34" charset="-122"/>
@@ -6866,7 +6922,7 @@
             <a:r>
               <a:rPr lang="en-US" sz="1800" b="1" dirty="0">
                 <a:solidFill>
-                  <a:srgbClr val="C8A04A"/>
+                  <a:srgbClr val="B8315A"/>
                 </a:solidFill>
                 <a:latin typeface="Arial" pitchFamily="34" charset="0"/>
                 <a:ea typeface="Arial" pitchFamily="34" charset="-122"/>
@@ -6905,7 +6961,7 @@
             <a:r>
               <a:rPr lang="en-US" sz="1500" dirty="0">
                 <a:solidFill>
-                  <a:srgbClr val="1B2733"/>
+                  <a:srgbClr val="221A1D"/>
                 </a:solidFill>
                 <a:latin typeface="Calibri" pitchFamily="34" charset="0"/>
                 <a:ea typeface="Calibri" pitchFamily="34" charset="-122"/>
@@ -6932,11 +6988,11 @@
             <a:avLst/>
           </a:prstGeom>
           <a:solidFill>
-            <a:srgbClr val="C8A04A"/>
+            <a:srgbClr val="D6D9DE"/>
           </a:solidFill>
           <a:ln w="12700">
             <a:solidFill>
-              <a:srgbClr val="C8A04A"/>
+              <a:srgbClr val="D6D9DE"/>
             </a:solidFill>
             <a:prstDash val="solid"/>
           </a:ln>
@@ -7032,7 +7088,7 @@
             <a:r>
               <a:rPr lang="en-US" sz="900" b="1" spc="400" kern="0" dirty="0">
                 <a:solidFill>
-                  <a:srgbClr val="C8A04A"/>
+                  <a:srgbClr val="D6D9DE"/>
                 </a:solidFill>
                 <a:latin typeface="Arial" pitchFamily="34" charset="0"/>
                 <a:ea typeface="Arial" pitchFamily="34" charset="-122"/>
@@ -7092,8 +7148,8 @@
         </p:blipFill>
         <p:spPr>
           <a:xfrm>
-            <a:off x="7452360" y="274320"/>
-            <a:ext cx="1325880" cy="414337"/>
+            <a:off x="8211312" y="182880"/>
+            <a:ext cx="566928" cy="566928"/>
           </a:xfrm>
           <a:prstGeom prst="rect">
             <a:avLst/>
@@ -7127,7 +7183,7 @@
             <a:r>
               <a:rPr lang="en-US" sz="1000" b="1" spc="400" kern="0" dirty="0">
                 <a:solidFill>
-                  <a:srgbClr val="C8A04A"/>
+                  <a:srgbClr val="B8315A"/>
                 </a:solidFill>
                 <a:latin typeface="Arial" pitchFamily="34" charset="0"/>
                 <a:ea typeface="Arial" pitchFamily="34" charset="-122"/>
@@ -7166,7 +7222,7 @@
             <a:r>
               <a:rPr lang="en-US" sz="800" spc="300" kern="0" dirty="0">
                 <a:solidFill>
-                  <a:srgbClr val="8A94A1"/>
+                  <a:srgbClr val="9A8C92"/>
                 </a:solidFill>
                 <a:latin typeface="Arial" pitchFamily="34" charset="0"/>
                 <a:ea typeface="Arial" pitchFamily="34" charset="-122"/>
@@ -7205,7 +7261,7 @@
             <a:r>
               <a:rPr lang="en-US" sz="800" dirty="0">
                 <a:solidFill>
-                  <a:srgbClr val="8A94A1"/>
+                  <a:srgbClr val="9A8C92"/>
                 </a:solidFill>
                 <a:latin typeface="Arial" pitchFamily="34" charset="0"/>
                 <a:ea typeface="Arial" pitchFamily="34" charset="-122"/>
@@ -7244,7 +7300,7 @@
             <a:r>
               <a:rPr lang="en-US" sz="3000" b="1" dirty="0">
                 <a:solidFill>
-                  <a:srgbClr val="0B1F33"/>
+                  <a:srgbClr val="4A0F26"/>
                 </a:solidFill>
                 <a:latin typeface="Arial" pitchFamily="34" charset="0"/>
                 <a:ea typeface="Arial" pitchFamily="34" charset="-122"/>
@@ -7273,7 +7329,7 @@
             </a:avLst>
           </a:prstGeom>
           <a:solidFill>
-            <a:srgbClr val="F4F6F9"/>
+            <a:srgbClr val="F6F4F5"/>
           </a:solidFill>
           <a:ln w="12700">
             <a:solidFill>
@@ -7298,11 +7354,11 @@
             <a:avLst/>
           </a:prstGeom>
           <a:solidFill>
-            <a:srgbClr val="0B1F33"/>
+            <a:srgbClr val="4A0F26"/>
           </a:solidFill>
           <a:ln w="12700">
             <a:solidFill>
-              <a:srgbClr val="0B1F33"/>
+              <a:srgbClr val="4A0F26"/>
             </a:solidFill>
             <a:prstDash val="solid"/>
           </a:ln>
@@ -7359,7 +7415,7 @@
             <a:r>
               <a:rPr lang="en-US" sz="1300" dirty="0">
                 <a:solidFill>
-                  <a:srgbClr val="1B2733"/>
+                  <a:srgbClr val="221A1D"/>
                 </a:solidFill>
                 <a:latin typeface="Calibri" pitchFamily="34" charset="0"/>
                 <a:ea typeface="Calibri" pitchFamily="34" charset="-122"/>
@@ -7388,7 +7444,7 @@
             </a:avLst>
           </a:prstGeom>
           <a:solidFill>
-            <a:srgbClr val="F4F6F9"/>
+            <a:srgbClr val="F6F4F5"/>
           </a:solidFill>
           <a:ln w="12700">
             <a:solidFill>
@@ -7413,11 +7469,11 @@
             <a:avLst/>
           </a:prstGeom>
           <a:solidFill>
-            <a:srgbClr val="0B1F33"/>
+            <a:srgbClr val="4A0F26"/>
           </a:solidFill>
           <a:ln w="12700">
             <a:solidFill>
-              <a:srgbClr val="0B1F33"/>
+              <a:srgbClr val="4A0F26"/>
             </a:solidFill>
             <a:prstDash val="solid"/>
           </a:ln>
@@ -7474,7 +7530,7 @@
             <a:r>
               <a:rPr lang="en-US" sz="1300" dirty="0">
                 <a:solidFill>
-                  <a:srgbClr val="1B2733"/>
+                  <a:srgbClr val="221A1D"/>
                 </a:solidFill>
                 <a:latin typeface="Calibri" pitchFamily="34" charset="0"/>
                 <a:ea typeface="Calibri" pitchFamily="34" charset="-122"/>
@@ -7503,7 +7559,7 @@
             </a:avLst>
           </a:prstGeom>
           <a:solidFill>
-            <a:srgbClr val="F4F6F9"/>
+            <a:srgbClr val="F6F4F5"/>
           </a:solidFill>
           <a:ln w="12700">
             <a:solidFill>
@@ -7528,11 +7584,11 @@
             <a:avLst/>
           </a:prstGeom>
           <a:solidFill>
-            <a:srgbClr val="0B1F33"/>
+            <a:srgbClr val="4A0F26"/>
           </a:solidFill>
           <a:ln w="12700">
             <a:solidFill>
-              <a:srgbClr val="0B1F33"/>
+              <a:srgbClr val="4A0F26"/>
             </a:solidFill>
             <a:prstDash val="solid"/>
           </a:ln>
@@ -7589,7 +7645,7 @@
             <a:r>
               <a:rPr lang="en-US" sz="1300" dirty="0">
                 <a:solidFill>
-                  <a:srgbClr val="1B2733"/>
+                  <a:srgbClr val="221A1D"/>
                 </a:solidFill>
                 <a:latin typeface="Calibri" pitchFamily="34" charset="0"/>
                 <a:ea typeface="Calibri" pitchFamily="34" charset="-122"/>
@@ -7618,7 +7674,7 @@
             </a:avLst>
           </a:prstGeom>
           <a:solidFill>
-            <a:srgbClr val="F4F6F9"/>
+            <a:srgbClr val="F6F4F5"/>
           </a:solidFill>
           <a:ln w="12700">
             <a:solidFill>
@@ -7643,11 +7699,11 @@
             <a:avLst/>
           </a:prstGeom>
           <a:solidFill>
-            <a:srgbClr val="0B1F33"/>
+            <a:srgbClr val="4A0F26"/>
           </a:solidFill>
           <a:ln w="12700">
             <a:solidFill>
-              <a:srgbClr val="0B1F33"/>
+              <a:srgbClr val="4A0F26"/>
             </a:solidFill>
             <a:prstDash val="solid"/>
           </a:ln>
@@ -7704,7 +7760,7 @@
             <a:r>
               <a:rPr lang="en-US" sz="1300" dirty="0">
                 <a:solidFill>
-                  <a:srgbClr val="1B2733"/>
+                  <a:srgbClr val="221A1D"/>
                 </a:solidFill>
                 <a:latin typeface="Calibri" pitchFamily="34" charset="0"/>
                 <a:ea typeface="Calibri" pitchFamily="34" charset="-122"/>
@@ -7733,11 +7789,11 @@
             </a:avLst>
           </a:prstGeom>
           <a:solidFill>
-            <a:srgbClr val="0B1F33"/>
+            <a:srgbClr val="4A0F26"/>
           </a:solidFill>
           <a:ln w="12700">
             <a:solidFill>
-              <a:srgbClr val="0B1F33"/>
+              <a:srgbClr val="4A0F26"/>
             </a:solidFill>
             <a:prstDash val="solid"/>
           </a:ln>
@@ -7758,11 +7814,11 @@
             <a:avLst/>
           </a:prstGeom>
           <a:solidFill>
-            <a:srgbClr val="C8A04A"/>
+            <a:srgbClr val="D6D9DE"/>
           </a:solidFill>
           <a:ln w="12700">
             <a:solidFill>
-              <a:srgbClr val="C8A04A"/>
+              <a:srgbClr val="D6D9DE"/>
             </a:solidFill>
             <a:prstDash val="solid"/>
           </a:ln>
@@ -7886,8 +7942,8 @@
         </p:blipFill>
         <p:spPr>
           <a:xfrm>
-            <a:off x="7452360" y="274320"/>
-            <a:ext cx="1325880" cy="414337"/>
+            <a:off x="8211312" y="182880"/>
+            <a:ext cx="566928" cy="566928"/>
           </a:xfrm>
           <a:prstGeom prst="rect">
             <a:avLst/>
@@ -7948,7 +8004,7 @@
             <a:r>
               <a:rPr lang="en-US" sz="3000" dirty="0">
                 <a:solidFill>
-                  <a:srgbClr val="D5DEE8"/>
+                  <a:srgbClr val="F1E1E7"/>
                 </a:solidFill>
                 <a:latin typeface="Cambria" pitchFamily="34" charset="0"/>
                 <a:ea typeface="Cambria" pitchFamily="34" charset="-122"/>
@@ -7985,7 +8041,7 @@
             <a:r>
               <a:rPr lang="en-US" sz="3000" b="1" dirty="0">
                 <a:solidFill>
-                  <a:srgbClr val="C8A04A"/>
+                  <a:srgbClr val="F2A7BD"/>
                 </a:solidFill>
                 <a:latin typeface="Cambria" pitchFamily="34" charset="0"/>
                 <a:ea typeface="Cambria" pitchFamily="34" charset="-122"/>
@@ -8024,7 +8080,7 @@
             <a:r>
               <a:rPr lang="en-US" sz="1100" b="1" spc="600" kern="0" dirty="0">
                 <a:solidFill>
-                  <a:srgbClr val="C8A04A"/>
+                  <a:srgbClr val="D6D9DE"/>
                 </a:solidFill>
                 <a:latin typeface="Arial" pitchFamily="34" charset="0"/>
                 <a:ea typeface="Arial" pitchFamily="34" charset="-122"/>
@@ -8063,7 +8119,7 @@
             <a:r>
               <a:rPr lang="en-US" sz="1000" dirty="0">
                 <a:solidFill>
-                  <a:srgbClr val="8FA3B8"/>
+                  <a:srgbClr val="D2B3BF"/>
                 </a:solidFill>
                 <a:latin typeface="Arial" pitchFamily="34" charset="0"/>
                 <a:ea typeface="Arial" pitchFamily="34" charset="-122"/>

</xml_diff>